<commit_message>
Add presentation video and update PPT with embedded video
- assignment1_presentation.mp4: narrated video with presenter overlay,
  blurred background bubble, slide transitions, and voice sync
- RPA_Onboarding_Presentation.pptx: updated with video embedded on each slide

Co-Authored-By: Claude Sonnet 4.6 <noreply@anthropic.com>
</commit_message>
<xml_diff>
--- a/Assignment No 01/RPA_Onboarding_Presentation.pptx
+++ b/Assignment No 01/RPA_Onboarding_Presentation.pptx
@@ -5455,11 +5455,66 @@
           </a:p>
         </p:txBody>
       </p:sp>
+      <p:pic>
+        <p:nvPicPr>
+          <p:cNvPr id="20" name="assignment1_presentation.mp4">
+            <a:hlinkClick r:id="" action="ppaction://media"/>
+          </p:cNvPr>
+          <p:cNvPicPr>
+            <a:picLocks noChangeAspect="1"/>
+          </p:cNvPicPr>
+          <p:nvPr>
+            <a:videoFile r:link="rId4"/>
+            <p:extLst>
+              <p:ext uri="{DAA4B4D4-6D71-4841-9C94-3DE7FCFB9230}">
+                <p14:media xmlns:p14="http://schemas.microsoft.com/office/powerpoint/2010/main" r:embed="rId3"/>
+              </p:ext>
+            </p:extLst>
+          </p:nvPr>
+        </p:nvPicPr>
+        <p:blipFill>
+          <a:blip r:embed="rId5"/>
+          <a:stretch>
+            <a:fillRect/>
+          </a:stretch>
+        </p:blipFill>
+        <p:spPr>
+          <a:xfrm>
+            <a:off x="8166599" y="5760720"/>
+            <a:ext cx="3900464" cy="1028700"/>
+          </a:xfrm>
+          <a:prstGeom prst="rect">
+            <a:avLst/>
+          </a:prstGeom>
+        </p:spPr>
+      </p:pic>
     </p:spTree>
   </p:cSld>
   <p:clrMapOvr>
     <a:masterClrMapping/>
   </p:clrMapOvr>
+  <p:timing>
+    <p:tnLst>
+      <p:par>
+        <p:cTn id="1" dur="indefinite" restart="never" nodeType="tmRoot">
+          <p:childTnLst>
+            <p:video>
+              <p:cMediaNode vol="80000">
+                <p:cTn id="2" fill="hold" display="0">
+                  <p:stCondLst>
+                    <p:cond delay="indefinite"/>
+                  </p:stCondLst>
+                </p:cTn>
+                <p:tgtEl>
+                  <p:spTgt spid="20"/>
+                </p:tgtEl>
+              </p:cMediaNode>
+            </p:video>
+          </p:childTnLst>
+        </p:cTn>
+      </p:par>
+    </p:tnLst>
+  </p:timing>
 </p:sld>
 </file>
 
@@ -6438,11 +6493,66 @@
           </a:p>
         </p:txBody>
       </p:sp>
+      <p:pic>
+        <p:nvPicPr>
+          <p:cNvPr id="28" name="assignment1_presentation.mp4">
+            <a:hlinkClick r:id="" action="ppaction://media"/>
+          </p:cNvPr>
+          <p:cNvPicPr>
+            <a:picLocks noChangeAspect="1"/>
+          </p:cNvPicPr>
+          <p:nvPr>
+            <a:videoFile r:link="rId4"/>
+            <p:extLst>
+              <p:ext uri="{DAA4B4D4-6D71-4841-9C94-3DE7FCFB9230}">
+                <p14:media xmlns:p14="http://schemas.microsoft.com/office/powerpoint/2010/main" r:embed="rId3"/>
+              </p:ext>
+            </p:extLst>
+          </p:nvPr>
+        </p:nvPicPr>
+        <p:blipFill>
+          <a:blip r:embed="rId5"/>
+          <a:stretch>
+            <a:fillRect/>
+          </a:stretch>
+        </p:blipFill>
+        <p:spPr>
+          <a:xfrm>
+            <a:off x="8166599" y="5760720"/>
+            <a:ext cx="3900464" cy="1028700"/>
+          </a:xfrm>
+          <a:prstGeom prst="rect">
+            <a:avLst/>
+          </a:prstGeom>
+        </p:spPr>
+      </p:pic>
     </p:spTree>
   </p:cSld>
   <p:clrMapOvr>
     <a:masterClrMapping/>
   </p:clrMapOvr>
+  <p:timing>
+    <p:tnLst>
+      <p:par>
+        <p:cTn id="1" dur="indefinite" restart="never" nodeType="tmRoot">
+          <p:childTnLst>
+            <p:video>
+              <p:cMediaNode vol="80000">
+                <p:cTn id="2" fill="hold" display="0">
+                  <p:stCondLst>
+                    <p:cond delay="indefinite"/>
+                  </p:stCondLst>
+                </p:cTn>
+                <p:tgtEl>
+                  <p:spTgt spid="28"/>
+                </p:tgtEl>
+              </p:cMediaNode>
+            </p:video>
+          </p:childTnLst>
+        </p:cTn>
+      </p:par>
+    </p:tnLst>
+  </p:timing>
 </p:sld>
 </file>
 
@@ -7942,11 +8052,66 @@
           </a:p>
         </p:txBody>
       </p:sp>
+      <p:pic>
+        <p:nvPicPr>
+          <p:cNvPr id="41" name="assignment1_presentation.mp4">
+            <a:hlinkClick r:id="" action="ppaction://media"/>
+          </p:cNvPr>
+          <p:cNvPicPr>
+            <a:picLocks noChangeAspect="1"/>
+          </p:cNvPicPr>
+          <p:nvPr>
+            <a:videoFile r:link="rId4"/>
+            <p:extLst>
+              <p:ext uri="{DAA4B4D4-6D71-4841-9C94-3DE7FCFB9230}">
+                <p14:media xmlns:p14="http://schemas.microsoft.com/office/powerpoint/2010/main" r:embed="rId3"/>
+              </p:ext>
+            </p:extLst>
+          </p:nvPr>
+        </p:nvPicPr>
+        <p:blipFill>
+          <a:blip r:embed="rId5"/>
+          <a:stretch>
+            <a:fillRect/>
+          </a:stretch>
+        </p:blipFill>
+        <p:spPr>
+          <a:xfrm>
+            <a:off x="8166599" y="5760720"/>
+            <a:ext cx="3900464" cy="1028700"/>
+          </a:xfrm>
+          <a:prstGeom prst="rect">
+            <a:avLst/>
+          </a:prstGeom>
+        </p:spPr>
+      </p:pic>
     </p:spTree>
   </p:cSld>
   <p:clrMapOvr>
     <a:masterClrMapping/>
   </p:clrMapOvr>
+  <p:timing>
+    <p:tnLst>
+      <p:par>
+        <p:cTn id="1" dur="indefinite" restart="never" nodeType="tmRoot">
+          <p:childTnLst>
+            <p:video>
+              <p:cMediaNode vol="80000">
+                <p:cTn id="2" fill="hold" display="0">
+                  <p:stCondLst>
+                    <p:cond delay="indefinite"/>
+                  </p:stCondLst>
+                </p:cTn>
+                <p:tgtEl>
+                  <p:spTgt spid="41"/>
+                </p:tgtEl>
+              </p:cMediaNode>
+            </p:video>
+          </p:childTnLst>
+        </p:cTn>
+      </p:par>
+    </p:tnLst>
+  </p:timing>
 </p:sld>
 </file>
 
@@ -8588,11 +8753,66 @@
           </a:p>
         </p:txBody>
       </p:sp>
+      <p:pic>
+        <p:nvPicPr>
+          <p:cNvPr id="17" name="assignment1_presentation.mp4">
+            <a:hlinkClick r:id="" action="ppaction://media"/>
+          </p:cNvPr>
+          <p:cNvPicPr>
+            <a:picLocks noChangeAspect="1"/>
+          </p:cNvPicPr>
+          <p:nvPr>
+            <a:videoFile r:link="rId4"/>
+            <p:extLst>
+              <p:ext uri="{DAA4B4D4-6D71-4841-9C94-3DE7FCFB9230}">
+                <p14:media xmlns:p14="http://schemas.microsoft.com/office/powerpoint/2010/main" r:embed="rId3"/>
+              </p:ext>
+            </p:extLst>
+          </p:nvPr>
+        </p:nvPicPr>
+        <p:blipFill>
+          <a:blip r:embed="rId5"/>
+          <a:stretch>
+            <a:fillRect/>
+          </a:stretch>
+        </p:blipFill>
+        <p:spPr>
+          <a:xfrm>
+            <a:off x="8166599" y="5760720"/>
+            <a:ext cx="3900464" cy="1028700"/>
+          </a:xfrm>
+          <a:prstGeom prst="rect">
+            <a:avLst/>
+          </a:prstGeom>
+        </p:spPr>
+      </p:pic>
     </p:spTree>
   </p:cSld>
   <p:clrMapOvr>
     <a:masterClrMapping/>
   </p:clrMapOvr>
+  <p:timing>
+    <p:tnLst>
+      <p:par>
+        <p:cTn id="1" dur="indefinite" restart="never" nodeType="tmRoot">
+          <p:childTnLst>
+            <p:video>
+              <p:cMediaNode vol="80000">
+                <p:cTn id="2" fill="hold" display="0">
+                  <p:stCondLst>
+                    <p:cond delay="indefinite"/>
+                  </p:stCondLst>
+                </p:cTn>
+                <p:tgtEl>
+                  <p:spTgt spid="17"/>
+                </p:tgtEl>
+              </p:cMediaNode>
+            </p:video>
+          </p:childTnLst>
+        </p:cTn>
+      </p:par>
+    </p:tnLst>
+  </p:timing>
 </p:sld>
 </file>
 
@@ -10119,11 +10339,66 @@
           </a:p>
         </p:txBody>
       </p:sp>
+      <p:pic>
+        <p:nvPicPr>
+          <p:cNvPr id="42" name="assignment1_presentation.mp4">
+            <a:hlinkClick r:id="" action="ppaction://media"/>
+          </p:cNvPr>
+          <p:cNvPicPr>
+            <a:picLocks noChangeAspect="1"/>
+          </p:cNvPicPr>
+          <p:nvPr>
+            <a:videoFile r:link="rId4"/>
+            <p:extLst>
+              <p:ext uri="{DAA4B4D4-6D71-4841-9C94-3DE7FCFB9230}">
+                <p14:media xmlns:p14="http://schemas.microsoft.com/office/powerpoint/2010/main" r:embed="rId3"/>
+              </p:ext>
+            </p:extLst>
+          </p:nvPr>
+        </p:nvPicPr>
+        <p:blipFill>
+          <a:blip r:embed="rId5"/>
+          <a:stretch>
+            <a:fillRect/>
+          </a:stretch>
+        </p:blipFill>
+        <p:spPr>
+          <a:xfrm>
+            <a:off x="8166599" y="5760720"/>
+            <a:ext cx="3900464" cy="1028700"/>
+          </a:xfrm>
+          <a:prstGeom prst="rect">
+            <a:avLst/>
+          </a:prstGeom>
+        </p:spPr>
+      </p:pic>
     </p:spTree>
   </p:cSld>
   <p:clrMapOvr>
     <a:masterClrMapping/>
   </p:clrMapOvr>
+  <p:timing>
+    <p:tnLst>
+      <p:par>
+        <p:cTn id="1" dur="indefinite" restart="never" nodeType="tmRoot">
+          <p:childTnLst>
+            <p:video>
+              <p:cMediaNode vol="80000">
+                <p:cTn id="2" fill="hold" display="0">
+                  <p:stCondLst>
+                    <p:cond delay="indefinite"/>
+                  </p:stCondLst>
+                </p:cTn>
+                <p:tgtEl>
+                  <p:spTgt spid="42"/>
+                </p:tgtEl>
+              </p:cMediaNode>
+            </p:video>
+          </p:childTnLst>
+        </p:cTn>
+      </p:par>
+    </p:tnLst>
+  </p:timing>
 </p:sld>
 </file>
 
@@ -11390,11 +11665,66 @@
           </a:p>
         </p:txBody>
       </p:sp>
+      <p:pic>
+        <p:nvPicPr>
+          <p:cNvPr id="37" name="assignment1_presentation.mp4">
+            <a:hlinkClick r:id="" action="ppaction://media"/>
+          </p:cNvPr>
+          <p:cNvPicPr>
+            <a:picLocks noChangeAspect="1"/>
+          </p:cNvPicPr>
+          <p:nvPr>
+            <a:videoFile r:link="rId4"/>
+            <p:extLst>
+              <p:ext uri="{DAA4B4D4-6D71-4841-9C94-3DE7FCFB9230}">
+                <p14:media xmlns:p14="http://schemas.microsoft.com/office/powerpoint/2010/main" r:embed="rId3"/>
+              </p:ext>
+            </p:extLst>
+          </p:nvPr>
+        </p:nvPicPr>
+        <p:blipFill>
+          <a:blip r:embed="rId5"/>
+          <a:stretch>
+            <a:fillRect/>
+          </a:stretch>
+        </p:blipFill>
+        <p:spPr>
+          <a:xfrm>
+            <a:off x="8166599" y="5760720"/>
+            <a:ext cx="3900464" cy="1028700"/>
+          </a:xfrm>
+          <a:prstGeom prst="rect">
+            <a:avLst/>
+          </a:prstGeom>
+        </p:spPr>
+      </p:pic>
     </p:spTree>
   </p:cSld>
   <p:clrMapOvr>
     <a:masterClrMapping/>
   </p:clrMapOvr>
+  <p:timing>
+    <p:tnLst>
+      <p:par>
+        <p:cTn id="1" dur="indefinite" restart="never" nodeType="tmRoot">
+          <p:childTnLst>
+            <p:video>
+              <p:cMediaNode vol="80000">
+                <p:cTn id="2" fill="hold" display="0">
+                  <p:stCondLst>
+                    <p:cond delay="indefinite"/>
+                  </p:stCondLst>
+                </p:cTn>
+                <p:tgtEl>
+                  <p:spTgt spid="37"/>
+                </p:tgtEl>
+              </p:cMediaNode>
+            </p:video>
+          </p:childTnLst>
+        </p:cTn>
+      </p:par>
+    </p:tnLst>
+  </p:timing>
 </p:sld>
 </file>
 
@@ -12115,11 +12445,66 @@
           </a:p>
         </p:txBody>
       </p:sp>
+      <p:pic>
+        <p:nvPicPr>
+          <p:cNvPr id="17" name="assignment1_presentation.mp4">
+            <a:hlinkClick r:id="" action="ppaction://media"/>
+          </p:cNvPr>
+          <p:cNvPicPr>
+            <a:picLocks noChangeAspect="1"/>
+          </p:cNvPicPr>
+          <p:nvPr>
+            <a:videoFile r:link="rId4"/>
+            <p:extLst>
+              <p:ext uri="{DAA4B4D4-6D71-4841-9C94-3DE7FCFB9230}">
+                <p14:media xmlns:p14="http://schemas.microsoft.com/office/powerpoint/2010/main" r:embed="rId3"/>
+              </p:ext>
+            </p:extLst>
+          </p:nvPr>
+        </p:nvPicPr>
+        <p:blipFill>
+          <a:blip r:embed="rId5"/>
+          <a:stretch>
+            <a:fillRect/>
+          </a:stretch>
+        </p:blipFill>
+        <p:spPr>
+          <a:xfrm>
+            <a:off x="8166599" y="5760720"/>
+            <a:ext cx="3900464" cy="1028700"/>
+          </a:xfrm>
+          <a:prstGeom prst="rect">
+            <a:avLst/>
+          </a:prstGeom>
+        </p:spPr>
+      </p:pic>
     </p:spTree>
   </p:cSld>
   <p:clrMapOvr>
     <a:masterClrMapping/>
   </p:clrMapOvr>
+  <p:timing>
+    <p:tnLst>
+      <p:par>
+        <p:cTn id="1" dur="indefinite" restart="never" nodeType="tmRoot">
+          <p:childTnLst>
+            <p:video>
+              <p:cMediaNode vol="80000">
+                <p:cTn id="2" fill="hold" display="0">
+                  <p:stCondLst>
+                    <p:cond delay="indefinite"/>
+                  </p:stCondLst>
+                </p:cTn>
+                <p:tgtEl>
+                  <p:spTgt spid="17"/>
+                </p:tgtEl>
+              </p:cMediaNode>
+            </p:video>
+          </p:childTnLst>
+        </p:cTn>
+      </p:par>
+    </p:tnLst>
+  </p:timing>
 </p:sld>
 </file>
 
@@ -13549,11 +13934,66 @@
           </a:p>
         </p:txBody>
       </p:sp>
+      <p:pic>
+        <p:nvPicPr>
+          <p:cNvPr id="41" name="assignment1_presentation.mp4">
+            <a:hlinkClick r:id="" action="ppaction://media"/>
+          </p:cNvPr>
+          <p:cNvPicPr>
+            <a:picLocks noChangeAspect="1"/>
+          </p:cNvPicPr>
+          <p:nvPr>
+            <a:videoFile r:link="rId4"/>
+            <p:extLst>
+              <p:ext uri="{DAA4B4D4-6D71-4841-9C94-3DE7FCFB9230}">
+                <p14:media xmlns:p14="http://schemas.microsoft.com/office/powerpoint/2010/main" r:embed="rId3"/>
+              </p:ext>
+            </p:extLst>
+          </p:nvPr>
+        </p:nvPicPr>
+        <p:blipFill>
+          <a:blip r:embed="rId5"/>
+          <a:stretch>
+            <a:fillRect/>
+          </a:stretch>
+        </p:blipFill>
+        <p:spPr>
+          <a:xfrm>
+            <a:off x="8166599" y="5760720"/>
+            <a:ext cx="3900464" cy="1028700"/>
+          </a:xfrm>
+          <a:prstGeom prst="rect">
+            <a:avLst/>
+          </a:prstGeom>
+        </p:spPr>
+      </p:pic>
     </p:spTree>
   </p:cSld>
   <p:clrMapOvr>
     <a:masterClrMapping/>
   </p:clrMapOvr>
+  <p:timing>
+    <p:tnLst>
+      <p:par>
+        <p:cTn id="1" dur="indefinite" restart="never" nodeType="tmRoot">
+          <p:childTnLst>
+            <p:video>
+              <p:cMediaNode vol="80000">
+                <p:cTn id="2" fill="hold" display="0">
+                  <p:stCondLst>
+                    <p:cond delay="indefinite"/>
+                  </p:stCondLst>
+                </p:cTn>
+                <p:tgtEl>
+                  <p:spTgt spid="41"/>
+                </p:tgtEl>
+              </p:cMediaNode>
+            </p:video>
+          </p:childTnLst>
+        </p:cTn>
+      </p:par>
+    </p:tnLst>
+  </p:timing>
 </p:sld>
 </file>
 
@@ -15997,11 +16437,66 @@
           </a:p>
         </p:txBody>
       </p:sp>
+      <p:pic>
+        <p:nvPicPr>
+          <p:cNvPr id="65" name="assignment1_presentation.mp4">
+            <a:hlinkClick r:id="" action="ppaction://media"/>
+          </p:cNvPr>
+          <p:cNvPicPr>
+            <a:picLocks noChangeAspect="1"/>
+          </p:cNvPicPr>
+          <p:nvPr>
+            <a:videoFile r:link="rId4"/>
+            <p:extLst>
+              <p:ext uri="{DAA4B4D4-6D71-4841-9C94-3DE7FCFB9230}">
+                <p14:media xmlns:p14="http://schemas.microsoft.com/office/powerpoint/2010/main" r:embed="rId3"/>
+              </p:ext>
+            </p:extLst>
+          </p:nvPr>
+        </p:nvPicPr>
+        <p:blipFill>
+          <a:blip r:embed="rId5"/>
+          <a:stretch>
+            <a:fillRect/>
+          </a:stretch>
+        </p:blipFill>
+        <p:spPr>
+          <a:xfrm>
+            <a:off x="8166599" y="5760720"/>
+            <a:ext cx="3900464" cy="1028700"/>
+          </a:xfrm>
+          <a:prstGeom prst="rect">
+            <a:avLst/>
+          </a:prstGeom>
+        </p:spPr>
+      </p:pic>
     </p:spTree>
   </p:cSld>
   <p:clrMapOvr>
     <a:masterClrMapping/>
   </p:clrMapOvr>
+  <p:timing>
+    <p:tnLst>
+      <p:par>
+        <p:cTn id="1" dur="indefinite" restart="never" nodeType="tmRoot">
+          <p:childTnLst>
+            <p:video>
+              <p:cMediaNode vol="80000">
+                <p:cTn id="2" fill="hold" display="0">
+                  <p:stCondLst>
+                    <p:cond delay="indefinite"/>
+                  </p:stCondLst>
+                </p:cTn>
+                <p:tgtEl>
+                  <p:spTgt spid="65"/>
+                </p:tgtEl>
+              </p:cMediaNode>
+            </p:video>
+          </p:childTnLst>
+        </p:cTn>
+      </p:par>
+    </p:tnLst>
+  </p:timing>
 </p:sld>
 </file>
 
@@ -17392,11 +17887,66 @@
           </a:p>
         </p:txBody>
       </p:sp>
+      <p:pic>
+        <p:nvPicPr>
+          <p:cNvPr id="38" name="assignment1_presentation.mp4">
+            <a:hlinkClick r:id="" action="ppaction://media"/>
+          </p:cNvPr>
+          <p:cNvPicPr>
+            <a:picLocks noChangeAspect="1"/>
+          </p:cNvPicPr>
+          <p:nvPr>
+            <a:videoFile r:link="rId4"/>
+            <p:extLst>
+              <p:ext uri="{DAA4B4D4-6D71-4841-9C94-3DE7FCFB9230}">
+                <p14:media xmlns:p14="http://schemas.microsoft.com/office/powerpoint/2010/main" r:embed="rId3"/>
+              </p:ext>
+            </p:extLst>
+          </p:nvPr>
+        </p:nvPicPr>
+        <p:blipFill>
+          <a:blip r:embed="rId5"/>
+          <a:stretch>
+            <a:fillRect/>
+          </a:stretch>
+        </p:blipFill>
+        <p:spPr>
+          <a:xfrm>
+            <a:off x="8166599" y="5760720"/>
+            <a:ext cx="3900464" cy="1028700"/>
+          </a:xfrm>
+          <a:prstGeom prst="rect">
+            <a:avLst/>
+          </a:prstGeom>
+        </p:spPr>
+      </p:pic>
     </p:spTree>
   </p:cSld>
   <p:clrMapOvr>
     <a:masterClrMapping/>
   </p:clrMapOvr>
+  <p:timing>
+    <p:tnLst>
+      <p:par>
+        <p:cTn id="1" dur="indefinite" restart="never" nodeType="tmRoot">
+          <p:childTnLst>
+            <p:video>
+              <p:cMediaNode vol="80000">
+                <p:cTn id="2" fill="hold" display="0">
+                  <p:stCondLst>
+                    <p:cond delay="indefinite"/>
+                  </p:stCondLst>
+                </p:cTn>
+                <p:tgtEl>
+                  <p:spTgt spid="38"/>
+                </p:tgtEl>
+              </p:cMediaNode>
+            </p:video>
+          </p:childTnLst>
+        </p:cTn>
+      </p:par>
+    </p:tnLst>
+  </p:timing>
 </p:sld>
 </file>
 

</xml_diff>